<commit_message>
Maya's scope: a launch on every plan is a launch; slide lines show the change only
- "Live for every plan" / "available to all users" / "rolls out to all tiers" no longer
  count as packaging. Packaging = something moved to or from a named plan, or became
  free ("now included in Core and Pro", "now free for all users", "previously
  Pro-only, now on Free"). Two independent reviewers and the owner agreed: sg-301/302
  are a launch (Noa's area).
- A third-party report of a skipped official launch says "Same event as <id>".
- Slides show the item's change in the page's own words, without "Update the … slide:".

Brief sample: 1 item (pr-401), 7 skipped. 148 tests pass; ./proof replays all weeks.

Co-Authored-By: Claude Opus 5.5 <noreply@anthropic.com>
</commit_message>
<xml_diff>
--- a/public/weeks/2026-W40/deck.pptx
+++ b/public/weeks/2026-W40/deck.pptx
@@ -3688,7 +3688,7 @@
                   <a:srgbClr val="18181B"/>
                 </a:solidFill>
               </a:rPr>
-              <a:t>Sep 30   Update the Bolt pricing slide: new on the page: "Bolt Lite ($9/month, invite only during the research preview) is powered by Bolt Forge and is the only AI mode on that plan.".</a:t>
+              <a:t>Sep 30   New on the page: "Bolt Lite ($9/month, invite only during the research preview) is powered by Bolt Forge and is the only AI mode on that plan."</a:t>
             </a:r>
           </a:p>
           <a:p>
@@ -3703,7 +3703,7 @@
                   <a:srgbClr val="18181B"/>
                 </a:solidFill>
               </a:rPr>
-              <a:t>Oct 1   Update the Bolt pricing slide: no longer on the page: "Bolt Lite ($9/month, invite only during the research preview) is powered by Bolt Forge and is the only AI mode on that plan.".</a:t>
+              <a:t>Oct 1   No longer on the page: "Bolt Lite ($9/month, invite only during the research preview) is powered by Bolt Forge and is the only AI mode on that plan."</a:t>
             </a:r>
           </a:p>
         </p:txBody>

</xml_diff>

<commit_message>
Recordings and site regenerated on main's data (one rebuild line)
Co-Authored-By: Claude Opus 5.5 <noreply@anthropic.com>
</commit_message>
<xml_diff>
--- a/public/weeks/2026-W40/deck.pptx
+++ b/public/weeks/2026-W40/deck.pptx
@@ -11,6 +11,7 @@
     <p:sldId id="259" r:id="rId10"/>
     <p:sldId id="260" r:id="rId11"/>
     <p:sldId id="261" r:id="rId12"/>
+    <p:sldId id="262" r:id="rId13"/>
   </p:sldIdLst>
   <p:sldSz cx="12192000" cy="6858000" type="screen4x3"/>
   <p:notesSz cx="6858000" cy="9144000"/>
@@ -3102,7 +3103,7 @@
         <p:spPr>
           <a:xfrm>
             <a:off x="660400" y="609600"/>
-            <a:ext cx="3556000" cy="5207000"/>
+            <a:ext cx="10871200" cy="5715000"/>
           </a:xfrm>
           <a:prstGeom prst="rect">
             <a:avLst/>
@@ -3110,38 +3111,295 @@
           <a:noFill/>
         </p:spPr>
         <p:txBody>
-          <a:bodyPr wrap="square">
+          <a:bodyPr wrap="square" lIns="0" rIns="0" tIns="0" bIns="0">
             <a:spAutoFit/>
           </a:bodyPr>
           <a:lstStyle/>
           <a:p>
             <a:pPr>
-              <a:spcAft>
-                <a:spcPts val="2160"/>
-              </a:spcAft>
+              <a:spcBef>
+                <a:spcPts val="0"/>
+              </a:spcBef>
             </a:pPr>
             <a:r>
-              <a:rPr sz="3600" b="1">
+              <a:rPr sz="900" b="0" cap="all" spc="90">
+                <a:solidFill>
+                  <a:srgbClr val="6B6964"/>
+                </a:solidFill>
+                <a:latin typeface="Inter"/>
+              </a:rPr>
+              <a:t>Competitor pages · Sep 28–Oct 4</a:t>
+            </a:r>
+          </a:p>
+          <a:p>
+            <a:pPr>
+              <a:spcBef>
+                <a:spcPts val="600"/>
+              </a:spcBef>
+            </a:pPr>
+            <a:r>
+              <a:rPr sz="4200" b="0" spc="-189">
                 <a:solidFill>
                   <a:srgbClr val="18181B"/>
                 </a:solidFill>
+                <a:latin typeface="Inter Tight"/>
+              </a:rPr>
+              <a:t>1 of 6 pages changed</a:t>
+            </a:r>
+          </a:p>
+          <a:p>
+            <a:pPr>
+              <a:spcBef>
+                <a:spcPts val="600"/>
+              </a:spcBef>
+            </a:pPr>
+            <a:r>
+              <a:rPr sz="1500" b="0">
+                <a:solidFill>
+                  <a:srgbClr val="6B6964"/>
+                </a:solidFill>
+                <a:latin typeface="Inter"/>
+              </a:rPr>
+              <a:t>Lovable, Replit and Bolt · pricing pages and homepages</a:t>
+            </a:r>
+          </a:p>
+          <a:p>
+            <a:pPr>
+              <a:spcBef>
+                <a:spcPts val="2400"/>
+              </a:spcBef>
+            </a:pPr>
+            <a:r>
+              <a:rPr sz="1200" b="0">
+                <a:solidFill>
+                  <a:srgbClr val="FF6A00"/>
+                </a:solidFill>
+                <a:latin typeface="Inter"/>
+              </a:rPr>
+              <a:t>●  </a:t>
+            </a:r>
+            <a:r>
+              <a:rPr sz="1600" b="1" u="sng">
+                <a:solidFill>
+                  <a:srgbClr val="18181B"/>
+                </a:solidFill>
+                <a:latin typeface="Inter"/>
+                <a:hlinkClick r:id="rId2"/>
+              </a:rPr>
+              <a:t>Bolt pricing</a:t>
+            </a:r>
+            <a:r>
+              <a:rPr sz="1600" b="0">
+                <a:solidFill>
+                  <a:srgbClr val="18181B"/>
+                </a:solidFill>
+                <a:latin typeface="Inter"/>
+              </a:rPr>
+              <a:t>    New on the page: "Bolt Lite ($9/month, invite only during the research preview) is powered by Bolt Forge and is the only AI mode on that plan."</a:t>
+            </a:r>
+            <a:r>
+              <a:rPr sz="1200" b="0">
+                <a:solidFill>
+                  <a:srgbClr val="6B6964"/>
+                </a:solidFill>
+                <a:latin typeface="Inter"/>
+              </a:rPr>
+              <a:t>    Sep 30</a:t>
+            </a:r>
+          </a:p>
+          <a:p>
+            <a:pPr>
+              <a:spcBef>
+                <a:spcPts val="200"/>
+              </a:spcBef>
+            </a:pPr>
+            <a:r>
+              <a:rPr sz="1200" b="0">
+                <a:solidFill>
+                  <a:srgbClr val="6B6964"/>
+                </a:solidFill>
+                <a:latin typeface="Inter"/>
+              </a:rPr>
+              <a:t>      Plus 1 more change</a:t>
+            </a:r>
+          </a:p>
+          <a:p>
+            <a:pPr>
+              <a:spcBef>
+                <a:spcPts val="1400"/>
+              </a:spcBef>
+            </a:pPr>
+            <a:r>
+              <a:rPr sz="1200" b="0">
+                <a:solidFill>
+                  <a:srgbClr val="D6D3CC"/>
+                </a:solidFill>
+                <a:latin typeface="Inter"/>
+              </a:rPr>
+              <a:t>●  </a:t>
+            </a:r>
+            <a:r>
+              <a:rPr sz="1400" b="0">
+                <a:solidFill>
+                  <a:srgbClr val="44423E"/>
+                </a:solidFill>
+                <a:latin typeface="Inter"/>
+              </a:rPr>
+              <a:t>No change    </a:t>
+            </a:r>
+            <a:r>
+              <a:rPr sz="1400" b="0" u="sng">
+                <a:solidFill>
+                  <a:srgbClr val="44423E"/>
+                </a:solidFill>
+                <a:latin typeface="Inter"/>
+                <a:hlinkClick r:id="rId3"/>
               </a:rPr>
               <a:t>Lovable pricing</a:t>
             </a:r>
+            <a:r>
+              <a:rPr sz="1400" b="0">
+                <a:solidFill>
+                  <a:srgbClr val="44423E"/>
+                </a:solidFill>
+                <a:latin typeface="Inter"/>
+              </a:rPr>
+              <a:t> · </a:t>
+            </a:r>
+            <a:r>
+              <a:rPr sz="1400" b="0" u="sng">
+                <a:solidFill>
+                  <a:srgbClr val="44423E"/>
+                </a:solidFill>
+                <a:latin typeface="Inter"/>
+                <a:hlinkClick r:id="rId4"/>
+              </a:rPr>
+              <a:t>Lovable homepage</a:t>
+            </a:r>
+            <a:r>
+              <a:rPr sz="1400" b="0">
+                <a:solidFill>
+                  <a:srgbClr val="44423E"/>
+                </a:solidFill>
+                <a:latin typeface="Inter"/>
+              </a:rPr>
+              <a:t> · </a:t>
+            </a:r>
+            <a:r>
+              <a:rPr sz="1400" b="0" u="sng">
+                <a:solidFill>
+                  <a:srgbClr val="44423E"/>
+                </a:solidFill>
+                <a:latin typeface="Inter"/>
+                <a:hlinkClick r:id="rId5"/>
+              </a:rPr>
+              <a:t>Replit pricing</a:t>
+            </a:r>
+            <a:r>
+              <a:rPr sz="1400" b="0">
+                <a:solidFill>
+                  <a:srgbClr val="44423E"/>
+                </a:solidFill>
+                <a:latin typeface="Inter"/>
+              </a:rPr>
+              <a:t> · </a:t>
+            </a:r>
+            <a:r>
+              <a:rPr sz="1400" b="0" u="sng">
+                <a:solidFill>
+                  <a:srgbClr val="44423E"/>
+                </a:solidFill>
+                <a:latin typeface="Inter"/>
+                <a:hlinkClick r:id="rId6"/>
+              </a:rPr>
+              <a:t>Replit homepage</a:t>
+            </a:r>
+            <a:r>
+              <a:rPr sz="1400" b="0">
+                <a:solidFill>
+                  <a:srgbClr val="44423E"/>
+                </a:solidFill>
+                <a:latin typeface="Inter"/>
+              </a:rPr>
+              <a:t> · </a:t>
+            </a:r>
+            <a:r>
+              <a:rPr sz="1400" b="0" u="sng">
+                <a:solidFill>
+                  <a:srgbClr val="44423E"/>
+                </a:solidFill>
+                <a:latin typeface="Inter"/>
+                <a:hlinkClick r:id="rId7"/>
+              </a:rPr>
+              <a:t>Bolt homepage</a:t>
+            </a:r>
           </a:p>
           <a:p>
             <a:pPr>
-              <a:spcAft>
-                <a:spcPts val="1080"/>
-              </a:spcAft>
+              <a:spcBef>
+                <a:spcPts val="1400"/>
+              </a:spcBef>
             </a:pPr>
             <a:r>
-              <a:rPr sz="1800" b="0">
-                <a:solidFill>
-                  <a:srgbClr val="52525B"/>
-                </a:solidFill>
-              </a:rPr>
-              <a:t>No change this week</a:t>
+              <a:rPr sz="1000" b="0">
+                <a:solidFill>
+                  <a:srgbClr val="92400E"/>
+                </a:solidFill>
+                <a:latin typeface="Inter"/>
+              </a:rPr>
+              <a:t>■  </a:t>
+            </a:r>
+            <a:r>
+              <a:rPr sz="1400" b="0">
+                <a:solidFill>
+                  <a:srgbClr val="44423E"/>
+                </a:solidFill>
+                <a:latin typeface="Inter"/>
+              </a:rPr>
+              <a:t>Check by hand    </a:t>
+            </a:r>
+            <a:r>
+              <a:rPr sz="1400" b="0">
+                <a:solidFill>
+                  <a:srgbClr val="44423E"/>
+                </a:solidFill>
+                <a:latin typeface="Inter"/>
+              </a:rPr>
+              <a:t>All 6 screenshots come from the Wayback Machine (Oct 2–4), so some may be a few days old.</a:t>
+            </a:r>
+          </a:p>
+          <a:p>
+            <a:pPr>
+              <a:spcBef>
+                <a:spcPts val="1400"/>
+              </a:spcBef>
+            </a:pPr>
+            <a:r>
+              <a:rPr sz="1000" b="0">
+                <a:solidFill>
+                  <a:srgbClr val="92400E"/>
+                </a:solidFill>
+                <a:latin typeface="Inter"/>
+              </a:rPr>
+              <a:t>■  </a:t>
+            </a:r>
+            <a:r>
+              <a:rPr sz="1400" b="0">
+                <a:solidFill>
+                  <a:srgbClr val="44423E"/>
+                </a:solidFill>
+                <a:latin typeface="Inter"/>
+              </a:rPr>
+              <a:t>Check by hand    </a:t>
+            </a:r>
+            <a:r>
+              <a:rPr sz="1400" b="0">
+                <a:solidFill>
+                  <a:srgbClr val="44423E"/>
+                </a:solidFill>
+                <a:latin typeface="Inter"/>
+              </a:rPr>
+              <a:t>The Replit pricing screenshot shows yearly prices (the archived copy can't switch to Monthly).</a:t>
             </a:r>
           </a:p>
         </p:txBody>
@@ -3154,8 +3412,8 @@
         </p:nvSpPr>
         <p:spPr>
           <a:xfrm>
-            <a:off x="660400" y="6223000"/>
-            <a:ext cx="10871200" cy="254000"/>
+            <a:off x="660400" y="6464300"/>
+            <a:ext cx="8890000" cy="190500"/>
           </a:xfrm>
           <a:prstGeom prst="rect">
             <a:avLst/>
@@ -3163,51 +3421,67 @@
           <a:noFill/>
         </p:spPr>
         <p:txBody>
-          <a:bodyPr wrap="square">
+          <a:bodyPr wrap="square" lIns="0" rIns="0" tIns="0" bIns="0">
             <a:spAutoFit/>
           </a:bodyPr>
           <a:lstStyle/>
           <a:p>
             <a:pPr>
-              <a:spcAft>
-                <a:spcPts val="600"/>
-              </a:spcAft>
+              <a:spcBef>
+                <a:spcPts val="0"/>
+              </a:spcBef>
             </a:pPr>
             <a:r>
-              <a:rPr sz="1000" b="0">
-                <a:solidFill>
-                  <a:srgbClr val="A1A1AA"/>
-                </a:solidFill>
-              </a:rPr>
-              <a:t>Week of Sep 28 · lovable.dev/pricing · screenshot Oct 4 (archived copy)    Competitor watch</a:t>
-            </a:r>
-          </a:p>
-        </p:txBody>
-      </p:sp>
-      <p:pic>
-        <p:nvPicPr>
-          <p:cNvPr id="4" name="Picture 3" descr="lovable-pricing.jpg"/>
-          <p:cNvPicPr>
-            <a:picLocks noChangeAspect="1"/>
-          </p:cNvPicPr>
+              <a:rPr sz="900" b="0">
+                <a:solidFill>
+                  <a:srgbClr val="8A8780"/>
+                </a:solidFill>
+                <a:latin typeface="Inter"/>
+              </a:rPr>
+              <a:t>Deck for Mon, Oct 5 · 6 pages · screenshots Oct 2–4 (6 archived copies)</a:t>
+            </a:r>
+          </a:p>
+        </p:txBody>
+      </p:sp>
+      <p:sp>
+        <p:nvSpPr>
+          <p:cNvPr id="4" name="TextBox 3"/>
+          <p:cNvSpPr txBox="1"/>
           <p:nvPr/>
-        </p:nvPicPr>
-        <p:blipFill>
-          <a:blip r:embed="rId2"/>
-          <a:stretch>
-            <a:fillRect/>
-          </a:stretch>
-        </p:blipFill>
+        </p:nvSpPr>
         <p:spPr>
           <a:xfrm>
-            <a:off x="4775200" y="609600"/>
-            <a:ext cx="6756400" cy="4691944"/>
+            <a:off x="9626600" y="6464300"/>
+            <a:ext cx="1905000" cy="190500"/>
           </a:xfrm>
           <a:prstGeom prst="rect">
             <a:avLst/>
           </a:prstGeom>
+          <a:noFill/>
         </p:spPr>
-      </p:pic>
+        <p:txBody>
+          <a:bodyPr wrap="square" lIns="0" rIns="0" tIns="0" bIns="0">
+            <a:spAutoFit/>
+          </a:bodyPr>
+          <a:lstStyle/>
+          <a:p>
+            <a:pPr algn="r">
+              <a:spcBef>
+                <a:spcPts val="0"/>
+              </a:spcBef>
+            </a:pPr>
+            <a:r>
+              <a:rPr sz="900" b="0">
+                <a:solidFill>
+                  <a:srgbClr val="8A8780"/>
+                </a:solidFill>
+                <a:latin typeface="Inter"/>
+              </a:rPr>
+              <a:t>Competitor watch</a:t>
+            </a:r>
+          </a:p>
+        </p:txBody>
+      </p:sp>
     </p:spTree>
   </p:cSld>
   <p:clrMapOvr>
@@ -3235,7 +3509,7 @@
         <p:spPr>
           <a:xfrm>
             <a:off x="660400" y="609600"/>
-            <a:ext cx="3556000" cy="5207000"/>
+            <a:ext cx="3778250" cy="5715000"/>
           </a:xfrm>
           <a:prstGeom prst="rect">
             <a:avLst/>
@@ -3243,36 +3517,63 @@
           <a:noFill/>
         </p:spPr>
         <p:txBody>
-          <a:bodyPr wrap="square">
+          <a:bodyPr wrap="square" lIns="0" rIns="0" tIns="0" bIns="0">
             <a:spAutoFit/>
           </a:bodyPr>
           <a:lstStyle/>
           <a:p>
             <a:pPr>
-              <a:spcAft>
-                <a:spcPts val="2160"/>
-              </a:spcAft>
+              <a:spcBef>
+                <a:spcPts val="0"/>
+              </a:spcBef>
             </a:pPr>
             <a:r>
-              <a:rPr sz="3600" b="1">
+              <a:rPr sz="900" b="0" cap="all" spc="90">
+                <a:solidFill>
+                  <a:srgbClr val="6B6964"/>
+                </a:solidFill>
+                <a:latin typeface="Inter"/>
+              </a:rPr>
+              <a:t>Lovable · Pricing page</a:t>
+            </a:r>
+          </a:p>
+          <a:p>
+            <a:pPr>
+              <a:spcBef>
+                <a:spcPts val="600"/>
+              </a:spcBef>
+            </a:pPr>
+            <a:r>
+              <a:rPr sz="4000" b="0" spc="-179">
                 <a:solidFill>
                   <a:srgbClr val="18181B"/>
                 </a:solidFill>
-              </a:rPr>
-              <a:t>Lovable homepage</a:t>
+                <a:latin typeface="Inter Tight"/>
+              </a:rPr>
+              <a:t>Lovable pricing</a:t>
             </a:r>
           </a:p>
           <a:p>
             <a:pPr>
-              <a:spcAft>
-                <a:spcPts val="1080"/>
-              </a:spcAft>
+              <a:spcBef>
+                <a:spcPts val="1000"/>
+              </a:spcBef>
             </a:pPr>
             <a:r>
-              <a:rPr sz="1800" b="0">
-                <a:solidFill>
-                  <a:srgbClr val="52525B"/>
-                </a:solidFill>
+              <a:rPr sz="1200" b="0">
+                <a:solidFill>
+                  <a:srgbClr val="D6D3CC"/>
+                </a:solidFill>
+                <a:latin typeface="Inter"/>
+              </a:rPr>
+              <a:t>●  </a:t>
+            </a:r>
+            <a:r>
+              <a:rPr sz="1400" b="0">
+                <a:solidFill>
+                  <a:srgbClr val="44423E"/>
+                </a:solidFill>
+                <a:latin typeface="Inter"/>
               </a:rPr>
               <a:t>No change this week</a:t>
             </a:r>
@@ -3281,14 +3582,106 @@
       </p:sp>
       <p:sp>
         <p:nvSpPr>
-          <p:cNvPr id="3" name="TextBox 2"/>
+          <p:cNvPr id="3" name="Rectangle 2">
+            <a:hlinkClick r:id="rId2"/>
+          </p:cNvPr>
+          <p:cNvSpPr/>
+          <p:nvPr/>
+        </p:nvSpPr>
+        <p:spPr>
+          <a:xfrm>
+            <a:off x="4972050" y="609600"/>
+            <a:ext cx="6559550" cy="279400"/>
+          </a:xfrm>
+          <a:prstGeom prst="rect">
+            <a:avLst/>
+          </a:prstGeom>
+          <a:solidFill>
+            <a:srgbClr val="F7F6F3"/>
+          </a:solidFill>
+          <a:ln>
+            <a:solidFill>
+              <a:srgbClr val="ECEAE5"/>
+            </a:solidFill>
+          </a:ln>
+          <a:effectLst/>
+        </p:spPr>
+        <p:style>
+          <a:lnRef idx="1">
+            <a:schemeClr val="accent1"/>
+          </a:lnRef>
+          <a:fillRef idx="3">
+            <a:schemeClr val="accent1"/>
+          </a:fillRef>
+          <a:effectRef idx="2">
+            <a:schemeClr val="accent1"/>
+          </a:effectRef>
+          <a:fontRef idx="minor">
+            <a:schemeClr val="lt1"/>
+          </a:fontRef>
+        </p:style>
+        <p:txBody>
+          <a:bodyPr rtlCol="0" anchor="ctr" lIns="127000"/>
+          <a:lstStyle/>
+          <a:p>
+            <a:pPr algn="l">
+              <a:spcBef>
+                <a:spcPts val="0"/>
+              </a:spcBef>
+            </a:pPr>
+            <a:r>
+              <a:rPr sz="900" b="0">
+                <a:solidFill>
+                  <a:srgbClr val="6B6964"/>
+                </a:solidFill>
+                <a:latin typeface="Geist Mono"/>
+              </a:rPr>
+              <a:t>lovable.dev/pricing</a:t>
+            </a:r>
+          </a:p>
+        </p:txBody>
+      </p:sp>
+      <p:pic>
+        <p:nvPicPr>
+          <p:cNvPr id="4" name="Picture 3" descr="lovable-pricing.jpg">
+            <a:hlinkClick r:id="rId2"/>
+          </p:cNvPr>
+          <p:cNvPicPr>
+            <a:picLocks noChangeAspect="1"/>
+          </p:cNvPicPr>
+          <p:nvPr/>
+        </p:nvPicPr>
+        <p:blipFill>
+          <a:blip r:embed="rId3"/>
+          <a:stretch>
+            <a:fillRect/>
+          </a:stretch>
+        </p:blipFill>
+        <p:spPr>
+          <a:xfrm>
+            <a:off x="4972050" y="889000"/>
+            <a:ext cx="6559550" cy="4555243"/>
+          </a:xfrm>
+          <a:prstGeom prst="rect">
+            <a:avLst/>
+          </a:prstGeom>
+          <a:ln>
+            <a:solidFill>
+              <a:srgbClr val="ECEAE5"/>
+            </a:solidFill>
+          </a:ln>
+        </p:spPr>
+      </p:pic>
+      <p:sp>
+        <p:nvSpPr>
+          <p:cNvPr id="5" name="TextBox 4"/>
           <p:cNvSpPr txBox="1"/>
           <p:nvPr/>
         </p:nvSpPr>
         <p:spPr>
           <a:xfrm>
-            <a:off x="660400" y="6223000"/>
-            <a:ext cx="10871200" cy="254000"/>
+            <a:off x="660400" y="6464300"/>
+            <a:ext cx="8890000" cy="190500"/>
           </a:xfrm>
           <a:prstGeom prst="rect">
             <a:avLst/>
@@ -3296,51 +3689,86 @@
           <a:noFill/>
         </p:spPr>
         <p:txBody>
-          <a:bodyPr wrap="square">
+          <a:bodyPr wrap="square" lIns="0" rIns="0" tIns="0" bIns="0">
             <a:spAutoFit/>
           </a:bodyPr>
           <a:lstStyle/>
           <a:p>
             <a:pPr>
-              <a:spcAft>
-                <a:spcPts val="600"/>
-              </a:spcAft>
+              <a:spcBef>
+                <a:spcPts val="0"/>
+              </a:spcBef>
             </a:pPr>
             <a:r>
-              <a:rPr sz="1000" b="0">
-                <a:solidFill>
-                  <a:srgbClr val="A1A1AA"/>
-                </a:solidFill>
-              </a:rPr>
-              <a:t>Week of Sep 28 · lovable.dev · screenshot Oct 3 (archived copy)    Competitor watch</a:t>
-            </a:r>
-          </a:p>
-        </p:txBody>
-      </p:sp>
-      <p:pic>
-        <p:nvPicPr>
-          <p:cNvPr id="4" name="Picture 3" descr="lovable-home.jpg"/>
-          <p:cNvPicPr>
-            <a:picLocks noChangeAspect="1"/>
-          </p:cNvPicPr>
+              <a:rPr sz="900" b="0">
+                <a:solidFill>
+                  <a:srgbClr val="8A8780"/>
+                </a:solidFill>
+                <a:latin typeface="Inter"/>
+              </a:rPr>
+              <a:t>Deck for Mon, Oct 5 · Source: </a:t>
+            </a:r>
+            <a:r>
+              <a:rPr sz="900" b="0" u="sng">
+                <a:solidFill>
+                  <a:srgbClr val="8A8780"/>
+                </a:solidFill>
+                <a:latin typeface="Inter"/>
+                <a:hlinkClick r:id="rId2"/>
+              </a:rPr>
+              <a:t>lovable.dev/pricing</a:t>
+            </a:r>
+            <a:r>
+              <a:rPr sz="900" b="0">
+                <a:solidFill>
+                  <a:srgbClr val="8A8780"/>
+                </a:solidFill>
+                <a:latin typeface="Inter"/>
+              </a:rPr>
+              <a:t> · Screenshot Oct 4 · archived copy</a:t>
+            </a:r>
+          </a:p>
+        </p:txBody>
+      </p:sp>
+      <p:sp>
+        <p:nvSpPr>
+          <p:cNvPr id="6" name="TextBox 5"/>
+          <p:cNvSpPr txBox="1"/>
           <p:nvPr/>
-        </p:nvPicPr>
-        <p:blipFill>
-          <a:blip r:embed="rId2"/>
-          <a:stretch>
-            <a:fillRect/>
-          </a:stretch>
-        </p:blipFill>
+        </p:nvSpPr>
         <p:spPr>
           <a:xfrm>
-            <a:off x="4775200" y="609600"/>
-            <a:ext cx="6756400" cy="4691944"/>
+            <a:off x="9626600" y="6464300"/>
+            <a:ext cx="1905000" cy="190500"/>
           </a:xfrm>
           <a:prstGeom prst="rect">
             <a:avLst/>
           </a:prstGeom>
+          <a:noFill/>
         </p:spPr>
-      </p:pic>
+        <p:txBody>
+          <a:bodyPr wrap="square" lIns="0" rIns="0" tIns="0" bIns="0">
+            <a:spAutoFit/>
+          </a:bodyPr>
+          <a:lstStyle/>
+          <a:p>
+            <a:pPr algn="r">
+              <a:spcBef>
+                <a:spcPts val="0"/>
+              </a:spcBef>
+            </a:pPr>
+            <a:r>
+              <a:rPr sz="900" b="0">
+                <a:solidFill>
+                  <a:srgbClr val="8A8780"/>
+                </a:solidFill>
+                <a:latin typeface="Inter"/>
+              </a:rPr>
+              <a:t>Competitor watch</a:t>
+            </a:r>
+          </a:p>
+        </p:txBody>
+      </p:sp>
     </p:spTree>
   </p:cSld>
   <p:clrMapOvr>
@@ -3368,7 +3796,7 @@
         <p:spPr>
           <a:xfrm>
             <a:off x="660400" y="609600"/>
-            <a:ext cx="3556000" cy="5207000"/>
+            <a:ext cx="3778250" cy="5715000"/>
           </a:xfrm>
           <a:prstGeom prst="rect">
             <a:avLst/>
@@ -3376,36 +3804,63 @@
           <a:noFill/>
         </p:spPr>
         <p:txBody>
-          <a:bodyPr wrap="square">
+          <a:bodyPr wrap="square" lIns="0" rIns="0" tIns="0" bIns="0">
             <a:spAutoFit/>
           </a:bodyPr>
           <a:lstStyle/>
           <a:p>
             <a:pPr>
-              <a:spcAft>
-                <a:spcPts val="2160"/>
-              </a:spcAft>
+              <a:spcBef>
+                <a:spcPts val="0"/>
+              </a:spcBef>
             </a:pPr>
             <a:r>
-              <a:rPr sz="3600" b="1">
+              <a:rPr sz="900" b="0" cap="all" spc="90">
+                <a:solidFill>
+                  <a:srgbClr val="6B6964"/>
+                </a:solidFill>
+                <a:latin typeface="Inter"/>
+              </a:rPr>
+              <a:t>Lovable · Homepage</a:t>
+            </a:r>
+          </a:p>
+          <a:p>
+            <a:pPr>
+              <a:spcBef>
+                <a:spcPts val="600"/>
+              </a:spcBef>
+            </a:pPr>
+            <a:r>
+              <a:rPr sz="4000" b="0" spc="-179">
                 <a:solidFill>
                   <a:srgbClr val="18181B"/>
                 </a:solidFill>
-              </a:rPr>
-              <a:t>Replit pricing</a:t>
+                <a:latin typeface="Inter Tight"/>
+              </a:rPr>
+              <a:t>Lovable homepage</a:t>
             </a:r>
           </a:p>
           <a:p>
             <a:pPr>
-              <a:spcAft>
-                <a:spcPts val="1080"/>
-              </a:spcAft>
+              <a:spcBef>
+                <a:spcPts val="1000"/>
+              </a:spcBef>
             </a:pPr>
             <a:r>
-              <a:rPr sz="1800" b="0">
-                <a:solidFill>
-                  <a:srgbClr val="52525B"/>
-                </a:solidFill>
+              <a:rPr sz="1200" b="0">
+                <a:solidFill>
+                  <a:srgbClr val="D6D3CC"/>
+                </a:solidFill>
+                <a:latin typeface="Inter"/>
+              </a:rPr>
+              <a:t>●  </a:t>
+            </a:r>
+            <a:r>
+              <a:rPr sz="1400" b="0">
+                <a:solidFill>
+                  <a:srgbClr val="44423E"/>
+                </a:solidFill>
+                <a:latin typeface="Inter"/>
               </a:rPr>
               <a:t>No change this week</a:t>
             </a:r>
@@ -3414,14 +3869,106 @@
       </p:sp>
       <p:sp>
         <p:nvSpPr>
-          <p:cNvPr id="3" name="TextBox 2"/>
+          <p:cNvPr id="3" name="Rectangle 2">
+            <a:hlinkClick r:id="rId2"/>
+          </p:cNvPr>
+          <p:cNvSpPr/>
+          <p:nvPr/>
+        </p:nvSpPr>
+        <p:spPr>
+          <a:xfrm>
+            <a:off x="4972050" y="609600"/>
+            <a:ext cx="6559550" cy="279400"/>
+          </a:xfrm>
+          <a:prstGeom prst="rect">
+            <a:avLst/>
+          </a:prstGeom>
+          <a:solidFill>
+            <a:srgbClr val="F7F6F3"/>
+          </a:solidFill>
+          <a:ln>
+            <a:solidFill>
+              <a:srgbClr val="ECEAE5"/>
+            </a:solidFill>
+          </a:ln>
+          <a:effectLst/>
+        </p:spPr>
+        <p:style>
+          <a:lnRef idx="1">
+            <a:schemeClr val="accent1"/>
+          </a:lnRef>
+          <a:fillRef idx="3">
+            <a:schemeClr val="accent1"/>
+          </a:fillRef>
+          <a:effectRef idx="2">
+            <a:schemeClr val="accent1"/>
+          </a:effectRef>
+          <a:fontRef idx="minor">
+            <a:schemeClr val="lt1"/>
+          </a:fontRef>
+        </p:style>
+        <p:txBody>
+          <a:bodyPr rtlCol="0" anchor="ctr" lIns="127000"/>
+          <a:lstStyle/>
+          <a:p>
+            <a:pPr algn="l">
+              <a:spcBef>
+                <a:spcPts val="0"/>
+              </a:spcBef>
+            </a:pPr>
+            <a:r>
+              <a:rPr sz="900" b="0">
+                <a:solidFill>
+                  <a:srgbClr val="6B6964"/>
+                </a:solidFill>
+                <a:latin typeface="Geist Mono"/>
+              </a:rPr>
+              <a:t>lovable.dev</a:t>
+            </a:r>
+          </a:p>
+        </p:txBody>
+      </p:sp>
+      <p:pic>
+        <p:nvPicPr>
+          <p:cNvPr id="4" name="Picture 3" descr="lovable-home.jpg">
+            <a:hlinkClick r:id="rId2"/>
+          </p:cNvPr>
+          <p:cNvPicPr>
+            <a:picLocks noChangeAspect="1"/>
+          </p:cNvPicPr>
+          <p:nvPr/>
+        </p:nvPicPr>
+        <p:blipFill>
+          <a:blip r:embed="rId3"/>
+          <a:stretch>
+            <a:fillRect/>
+          </a:stretch>
+        </p:blipFill>
+        <p:spPr>
+          <a:xfrm>
+            <a:off x="4972050" y="889000"/>
+            <a:ext cx="6559550" cy="4555243"/>
+          </a:xfrm>
+          <a:prstGeom prst="rect">
+            <a:avLst/>
+          </a:prstGeom>
+          <a:ln>
+            <a:solidFill>
+              <a:srgbClr val="ECEAE5"/>
+            </a:solidFill>
+          </a:ln>
+        </p:spPr>
+      </p:pic>
+      <p:sp>
+        <p:nvSpPr>
+          <p:cNvPr id="5" name="TextBox 4"/>
           <p:cNvSpPr txBox="1"/>
           <p:nvPr/>
         </p:nvSpPr>
         <p:spPr>
           <a:xfrm>
-            <a:off x="660400" y="6223000"/>
-            <a:ext cx="10871200" cy="254000"/>
+            <a:off x="660400" y="6464300"/>
+            <a:ext cx="8890000" cy="190500"/>
           </a:xfrm>
           <a:prstGeom prst="rect">
             <a:avLst/>
@@ -3429,51 +3976,86 @@
           <a:noFill/>
         </p:spPr>
         <p:txBody>
-          <a:bodyPr wrap="square">
+          <a:bodyPr wrap="square" lIns="0" rIns="0" tIns="0" bIns="0">
             <a:spAutoFit/>
           </a:bodyPr>
           <a:lstStyle/>
           <a:p>
             <a:pPr>
-              <a:spcAft>
-                <a:spcPts val="600"/>
-              </a:spcAft>
+              <a:spcBef>
+                <a:spcPts val="0"/>
+              </a:spcBef>
             </a:pPr>
             <a:r>
-              <a:rPr sz="1000" b="0">
-                <a:solidFill>
-                  <a:srgbClr val="A1A1AA"/>
-                </a:solidFill>
-              </a:rPr>
-              <a:t>Week of Sep 28 · replit.com/pricing · screenshot Oct 2 (archived copy)    Competitor watch</a:t>
-            </a:r>
-          </a:p>
-        </p:txBody>
-      </p:sp>
-      <p:pic>
-        <p:nvPicPr>
-          <p:cNvPr id="4" name="Picture 3" descr="replit-pricing.jpg"/>
-          <p:cNvPicPr>
-            <a:picLocks noChangeAspect="1"/>
-          </p:cNvPicPr>
+              <a:rPr sz="900" b="0">
+                <a:solidFill>
+                  <a:srgbClr val="8A8780"/>
+                </a:solidFill>
+                <a:latin typeface="Inter"/>
+              </a:rPr>
+              <a:t>Deck for Mon, Oct 5 · Source: </a:t>
+            </a:r>
+            <a:r>
+              <a:rPr sz="900" b="0" u="sng">
+                <a:solidFill>
+                  <a:srgbClr val="8A8780"/>
+                </a:solidFill>
+                <a:latin typeface="Inter"/>
+                <a:hlinkClick r:id="rId2"/>
+              </a:rPr>
+              <a:t>lovable.dev</a:t>
+            </a:r>
+            <a:r>
+              <a:rPr sz="900" b="0">
+                <a:solidFill>
+                  <a:srgbClr val="8A8780"/>
+                </a:solidFill>
+                <a:latin typeface="Inter"/>
+              </a:rPr>
+              <a:t> · Screenshot Oct 3 · archived copy</a:t>
+            </a:r>
+          </a:p>
+        </p:txBody>
+      </p:sp>
+      <p:sp>
+        <p:nvSpPr>
+          <p:cNvPr id="6" name="TextBox 5"/>
+          <p:cNvSpPr txBox="1"/>
           <p:nvPr/>
-        </p:nvPicPr>
-        <p:blipFill>
-          <a:blip r:embed="rId2"/>
-          <a:stretch>
-            <a:fillRect/>
-          </a:stretch>
-        </p:blipFill>
+        </p:nvSpPr>
         <p:spPr>
           <a:xfrm>
-            <a:off x="4775200" y="609600"/>
-            <a:ext cx="6756400" cy="4691944"/>
+            <a:off x="9626600" y="6464300"/>
+            <a:ext cx="1905000" cy="190500"/>
           </a:xfrm>
           <a:prstGeom prst="rect">
             <a:avLst/>
           </a:prstGeom>
+          <a:noFill/>
         </p:spPr>
-      </p:pic>
+        <p:txBody>
+          <a:bodyPr wrap="square" lIns="0" rIns="0" tIns="0" bIns="0">
+            <a:spAutoFit/>
+          </a:bodyPr>
+          <a:lstStyle/>
+          <a:p>
+            <a:pPr algn="r">
+              <a:spcBef>
+                <a:spcPts val="0"/>
+              </a:spcBef>
+            </a:pPr>
+            <a:r>
+              <a:rPr sz="900" b="0">
+                <a:solidFill>
+                  <a:srgbClr val="8A8780"/>
+                </a:solidFill>
+                <a:latin typeface="Inter"/>
+              </a:rPr>
+              <a:t>Competitor watch</a:t>
+            </a:r>
+          </a:p>
+        </p:txBody>
+      </p:sp>
     </p:spTree>
   </p:cSld>
   <p:clrMapOvr>
@@ -3501,7 +4083,7 @@
         <p:spPr>
           <a:xfrm>
             <a:off x="660400" y="609600"/>
-            <a:ext cx="3556000" cy="5207000"/>
+            <a:ext cx="3778250" cy="5715000"/>
           </a:xfrm>
           <a:prstGeom prst="rect">
             <a:avLst/>
@@ -3509,36 +4091,63 @@
           <a:noFill/>
         </p:spPr>
         <p:txBody>
-          <a:bodyPr wrap="square">
+          <a:bodyPr wrap="square" lIns="0" rIns="0" tIns="0" bIns="0">
             <a:spAutoFit/>
           </a:bodyPr>
           <a:lstStyle/>
           <a:p>
             <a:pPr>
-              <a:spcAft>
-                <a:spcPts val="2160"/>
-              </a:spcAft>
+              <a:spcBef>
+                <a:spcPts val="0"/>
+              </a:spcBef>
             </a:pPr>
             <a:r>
-              <a:rPr sz="3600" b="1">
+              <a:rPr sz="900" b="0" cap="all" spc="90">
+                <a:solidFill>
+                  <a:srgbClr val="6B6964"/>
+                </a:solidFill>
+                <a:latin typeface="Inter"/>
+              </a:rPr>
+              <a:t>Replit · Pricing page</a:t>
+            </a:r>
+          </a:p>
+          <a:p>
+            <a:pPr>
+              <a:spcBef>
+                <a:spcPts val="600"/>
+              </a:spcBef>
+            </a:pPr>
+            <a:r>
+              <a:rPr sz="4000" b="0" spc="-179">
                 <a:solidFill>
                   <a:srgbClr val="18181B"/>
                 </a:solidFill>
-              </a:rPr>
-              <a:t>Replit homepage</a:t>
+                <a:latin typeface="Inter Tight"/>
+              </a:rPr>
+              <a:t>Replit pricing</a:t>
             </a:r>
           </a:p>
           <a:p>
             <a:pPr>
-              <a:spcAft>
-                <a:spcPts val="1080"/>
-              </a:spcAft>
+              <a:spcBef>
+                <a:spcPts val="1000"/>
+              </a:spcBef>
             </a:pPr>
             <a:r>
-              <a:rPr sz="1800" b="0">
-                <a:solidFill>
-                  <a:srgbClr val="52525B"/>
-                </a:solidFill>
+              <a:rPr sz="1200" b="0">
+                <a:solidFill>
+                  <a:srgbClr val="D6D3CC"/>
+                </a:solidFill>
+                <a:latin typeface="Inter"/>
+              </a:rPr>
+              <a:t>●  </a:t>
+            </a:r>
+            <a:r>
+              <a:rPr sz="1400" b="0">
+                <a:solidFill>
+                  <a:srgbClr val="44423E"/>
+                </a:solidFill>
+                <a:latin typeface="Inter"/>
               </a:rPr>
               <a:t>No change this week</a:t>
             </a:r>
@@ -3547,14 +4156,106 @@
       </p:sp>
       <p:sp>
         <p:nvSpPr>
-          <p:cNvPr id="3" name="TextBox 2"/>
+          <p:cNvPr id="3" name="Rectangle 2">
+            <a:hlinkClick r:id="rId2"/>
+          </p:cNvPr>
+          <p:cNvSpPr/>
+          <p:nvPr/>
+        </p:nvSpPr>
+        <p:spPr>
+          <a:xfrm>
+            <a:off x="4972050" y="609600"/>
+            <a:ext cx="6559550" cy="279400"/>
+          </a:xfrm>
+          <a:prstGeom prst="rect">
+            <a:avLst/>
+          </a:prstGeom>
+          <a:solidFill>
+            <a:srgbClr val="F7F6F3"/>
+          </a:solidFill>
+          <a:ln>
+            <a:solidFill>
+              <a:srgbClr val="ECEAE5"/>
+            </a:solidFill>
+          </a:ln>
+          <a:effectLst/>
+        </p:spPr>
+        <p:style>
+          <a:lnRef idx="1">
+            <a:schemeClr val="accent1"/>
+          </a:lnRef>
+          <a:fillRef idx="3">
+            <a:schemeClr val="accent1"/>
+          </a:fillRef>
+          <a:effectRef idx="2">
+            <a:schemeClr val="accent1"/>
+          </a:effectRef>
+          <a:fontRef idx="minor">
+            <a:schemeClr val="lt1"/>
+          </a:fontRef>
+        </p:style>
+        <p:txBody>
+          <a:bodyPr rtlCol="0" anchor="ctr" lIns="127000"/>
+          <a:lstStyle/>
+          <a:p>
+            <a:pPr algn="l">
+              <a:spcBef>
+                <a:spcPts val="0"/>
+              </a:spcBef>
+            </a:pPr>
+            <a:r>
+              <a:rPr sz="900" b="0">
+                <a:solidFill>
+                  <a:srgbClr val="6B6964"/>
+                </a:solidFill>
+                <a:latin typeface="Geist Mono"/>
+              </a:rPr>
+              <a:t>replit.com/pricing</a:t>
+            </a:r>
+          </a:p>
+        </p:txBody>
+      </p:sp>
+      <p:pic>
+        <p:nvPicPr>
+          <p:cNvPr id="4" name="Picture 3" descr="replit-pricing.jpg">
+            <a:hlinkClick r:id="rId2"/>
+          </p:cNvPr>
+          <p:cNvPicPr>
+            <a:picLocks noChangeAspect="1"/>
+          </p:cNvPicPr>
+          <p:nvPr/>
+        </p:nvPicPr>
+        <p:blipFill>
+          <a:blip r:embed="rId3"/>
+          <a:stretch>
+            <a:fillRect/>
+          </a:stretch>
+        </p:blipFill>
+        <p:spPr>
+          <a:xfrm>
+            <a:off x="4972050" y="889000"/>
+            <a:ext cx="6559550" cy="4555243"/>
+          </a:xfrm>
+          <a:prstGeom prst="rect">
+            <a:avLst/>
+          </a:prstGeom>
+          <a:ln>
+            <a:solidFill>
+              <a:srgbClr val="ECEAE5"/>
+            </a:solidFill>
+          </a:ln>
+        </p:spPr>
+      </p:pic>
+      <p:sp>
+        <p:nvSpPr>
+          <p:cNvPr id="5" name="TextBox 4"/>
           <p:cNvSpPr txBox="1"/>
           <p:nvPr/>
         </p:nvSpPr>
         <p:spPr>
           <a:xfrm>
-            <a:off x="660400" y="6223000"/>
-            <a:ext cx="10871200" cy="254000"/>
+            <a:off x="660400" y="6464300"/>
+            <a:ext cx="8890000" cy="190500"/>
           </a:xfrm>
           <a:prstGeom prst="rect">
             <a:avLst/>
@@ -3562,51 +4263,86 @@
           <a:noFill/>
         </p:spPr>
         <p:txBody>
-          <a:bodyPr wrap="square">
+          <a:bodyPr wrap="square" lIns="0" rIns="0" tIns="0" bIns="0">
             <a:spAutoFit/>
           </a:bodyPr>
           <a:lstStyle/>
           <a:p>
             <a:pPr>
-              <a:spcAft>
-                <a:spcPts val="600"/>
-              </a:spcAft>
+              <a:spcBef>
+                <a:spcPts val="0"/>
+              </a:spcBef>
             </a:pPr>
             <a:r>
-              <a:rPr sz="1000" b="0">
-                <a:solidFill>
-                  <a:srgbClr val="A1A1AA"/>
-                </a:solidFill>
-              </a:rPr>
-              <a:t>Week of Sep 28 · replit.com · screenshot Oct 3 (archived copy)    Competitor watch</a:t>
-            </a:r>
-          </a:p>
-        </p:txBody>
-      </p:sp>
-      <p:pic>
-        <p:nvPicPr>
-          <p:cNvPr id="4" name="Picture 3" descr="replit-home.jpg"/>
-          <p:cNvPicPr>
-            <a:picLocks noChangeAspect="1"/>
-          </p:cNvPicPr>
+              <a:rPr sz="900" b="0">
+                <a:solidFill>
+                  <a:srgbClr val="8A8780"/>
+                </a:solidFill>
+                <a:latin typeface="Inter"/>
+              </a:rPr>
+              <a:t>Deck for Mon, Oct 5 · Source: </a:t>
+            </a:r>
+            <a:r>
+              <a:rPr sz="900" b="0" u="sng">
+                <a:solidFill>
+                  <a:srgbClr val="8A8780"/>
+                </a:solidFill>
+                <a:latin typeface="Inter"/>
+                <a:hlinkClick r:id="rId2"/>
+              </a:rPr>
+              <a:t>replit.com/pricing</a:t>
+            </a:r>
+            <a:r>
+              <a:rPr sz="900" b="0">
+                <a:solidFill>
+                  <a:srgbClr val="8A8780"/>
+                </a:solidFill>
+                <a:latin typeface="Inter"/>
+              </a:rPr>
+              <a:t> · Screenshot Oct 2 · archived copy · yearly prices shown</a:t>
+            </a:r>
+          </a:p>
+        </p:txBody>
+      </p:sp>
+      <p:sp>
+        <p:nvSpPr>
+          <p:cNvPr id="6" name="TextBox 5"/>
+          <p:cNvSpPr txBox="1"/>
           <p:nvPr/>
-        </p:nvPicPr>
-        <p:blipFill>
-          <a:blip r:embed="rId2"/>
-          <a:stretch>
-            <a:fillRect/>
-          </a:stretch>
-        </p:blipFill>
+        </p:nvSpPr>
         <p:spPr>
           <a:xfrm>
-            <a:off x="4775200" y="609600"/>
-            <a:ext cx="6756400" cy="4691944"/>
+            <a:off x="9626600" y="6464300"/>
+            <a:ext cx="1905000" cy="190500"/>
           </a:xfrm>
           <a:prstGeom prst="rect">
             <a:avLst/>
           </a:prstGeom>
+          <a:noFill/>
         </p:spPr>
-      </p:pic>
+        <p:txBody>
+          <a:bodyPr wrap="square" lIns="0" rIns="0" tIns="0" bIns="0">
+            <a:spAutoFit/>
+          </a:bodyPr>
+          <a:lstStyle/>
+          <a:p>
+            <a:pPr algn="r">
+              <a:spcBef>
+                <a:spcPts val="0"/>
+              </a:spcBef>
+            </a:pPr>
+            <a:r>
+              <a:rPr sz="900" b="0">
+                <a:solidFill>
+                  <a:srgbClr val="8A8780"/>
+                </a:solidFill>
+                <a:latin typeface="Inter"/>
+              </a:rPr>
+              <a:t>Competitor watch</a:t>
+            </a:r>
+          </a:p>
+        </p:txBody>
+      </p:sp>
     </p:spTree>
   </p:cSld>
   <p:clrMapOvr>
@@ -3634,7 +4370,7 @@
         <p:spPr>
           <a:xfrm>
             <a:off x="660400" y="609600"/>
-            <a:ext cx="3556000" cy="5207000"/>
+            <a:ext cx="3778250" cy="5715000"/>
           </a:xfrm>
           <a:prstGeom prst="rect">
             <a:avLst/>
@@ -3642,82 +4378,171 @@
           <a:noFill/>
         </p:spPr>
         <p:txBody>
-          <a:bodyPr wrap="square">
+          <a:bodyPr wrap="square" lIns="0" rIns="0" tIns="0" bIns="0">
             <a:spAutoFit/>
           </a:bodyPr>
           <a:lstStyle/>
           <a:p>
             <a:pPr>
-              <a:spcAft>
-                <a:spcPts val="2160"/>
-              </a:spcAft>
+              <a:spcBef>
+                <a:spcPts val="0"/>
+              </a:spcBef>
             </a:pPr>
             <a:r>
-              <a:rPr sz="3600" b="1">
+              <a:rPr sz="900" b="0" cap="all" spc="90">
+                <a:solidFill>
+                  <a:srgbClr val="6B6964"/>
+                </a:solidFill>
+                <a:latin typeface="Inter"/>
+              </a:rPr>
+              <a:t>Replit · Homepage</a:t>
+            </a:r>
+          </a:p>
+          <a:p>
+            <a:pPr>
+              <a:spcBef>
+                <a:spcPts val="600"/>
+              </a:spcBef>
+            </a:pPr>
+            <a:r>
+              <a:rPr sz="4000" b="0" spc="-179">
                 <a:solidFill>
                   <a:srgbClr val="18181B"/>
                 </a:solidFill>
-              </a:rPr>
-              <a:t>Bolt pricing</a:t>
+                <a:latin typeface="Inter Tight"/>
+              </a:rPr>
+              <a:t>Replit homepage</a:t>
             </a:r>
           </a:p>
           <a:p>
             <a:pPr>
-              <a:spcAft>
-                <a:spcPts val="1080"/>
-              </a:spcAft>
+              <a:spcBef>
+                <a:spcPts val="1000"/>
+              </a:spcBef>
             </a:pPr>
             <a:r>
-              <a:rPr sz="1800" b="0">
-                <a:solidFill>
-                  <a:srgbClr val="52525B"/>
-                </a:solidFill>
-              </a:rPr>
-              <a:t>Changed this week</a:t>
-            </a:r>
-          </a:p>
-          <a:p>
-            <a:pPr>
-              <a:spcAft>
-                <a:spcPts val="840"/>
-              </a:spcAft>
+              <a:rPr sz="1200" b="0">
+                <a:solidFill>
+                  <a:srgbClr val="D6D3CC"/>
+                </a:solidFill>
+                <a:latin typeface="Inter"/>
+              </a:rPr>
+              <a:t>●  </a:t>
+            </a:r>
+            <a:r>
+              <a:rPr sz="1400" b="0">
+                <a:solidFill>
+                  <a:srgbClr val="44423E"/>
+                </a:solidFill>
+                <a:latin typeface="Inter"/>
+              </a:rPr>
+              <a:t>No change this week</a:t>
+            </a:r>
+          </a:p>
+        </p:txBody>
+      </p:sp>
+      <p:sp>
+        <p:nvSpPr>
+          <p:cNvPr id="3" name="Rectangle 2">
+            <a:hlinkClick r:id="rId2"/>
+          </p:cNvPr>
+          <p:cNvSpPr/>
+          <p:nvPr/>
+        </p:nvSpPr>
+        <p:spPr>
+          <a:xfrm>
+            <a:off x="4972050" y="609600"/>
+            <a:ext cx="6559550" cy="279400"/>
+          </a:xfrm>
+          <a:prstGeom prst="rect">
+            <a:avLst/>
+          </a:prstGeom>
+          <a:solidFill>
+            <a:srgbClr val="F7F6F3"/>
+          </a:solidFill>
+          <a:ln>
+            <a:solidFill>
+              <a:srgbClr val="ECEAE5"/>
+            </a:solidFill>
+          </a:ln>
+          <a:effectLst/>
+        </p:spPr>
+        <p:style>
+          <a:lnRef idx="1">
+            <a:schemeClr val="accent1"/>
+          </a:lnRef>
+          <a:fillRef idx="3">
+            <a:schemeClr val="accent1"/>
+          </a:fillRef>
+          <a:effectRef idx="2">
+            <a:schemeClr val="accent1"/>
+          </a:effectRef>
+          <a:fontRef idx="minor">
+            <a:schemeClr val="lt1"/>
+          </a:fontRef>
+        </p:style>
+        <p:txBody>
+          <a:bodyPr rtlCol="0" anchor="ctr" lIns="127000"/>
+          <a:lstStyle/>
+          <a:p>
+            <a:pPr algn="l">
+              <a:spcBef>
+                <a:spcPts val="0"/>
+              </a:spcBef>
             </a:pPr>
             <a:r>
-              <a:rPr sz="1400" b="0">
-                <a:solidFill>
-                  <a:srgbClr val="18181B"/>
-                </a:solidFill>
-              </a:rPr>
-              <a:t>Sep 30   New on the page: "Bolt Lite ($9/month, invite only during the research preview) is powered by Bolt Forge and is the only AI mode on that plan."</a:t>
-            </a:r>
-          </a:p>
-          <a:p>
-            <a:pPr>
-              <a:spcAft>
-                <a:spcPts val="840"/>
-              </a:spcAft>
-            </a:pPr>
-            <a:r>
-              <a:rPr sz="1400" b="0">
-                <a:solidFill>
-                  <a:srgbClr val="18181B"/>
-                </a:solidFill>
-              </a:rPr>
-              <a:t>Oct 1   No longer on the page: "Bolt Lite ($9/month, invite only during the research preview) is powered by Bolt Forge and is the only AI mode on that plan."</a:t>
-            </a:r>
-          </a:p>
-        </p:txBody>
-      </p:sp>
-      <p:sp>
-        <p:nvSpPr>
-          <p:cNvPr id="3" name="TextBox 2"/>
+              <a:rPr sz="900" b="0">
+                <a:solidFill>
+                  <a:srgbClr val="6B6964"/>
+                </a:solidFill>
+                <a:latin typeface="Geist Mono"/>
+              </a:rPr>
+              <a:t>replit.com</a:t>
+            </a:r>
+          </a:p>
+        </p:txBody>
+      </p:sp>
+      <p:pic>
+        <p:nvPicPr>
+          <p:cNvPr id="4" name="Picture 3" descr="replit-home.jpg">
+            <a:hlinkClick r:id="rId2"/>
+          </p:cNvPr>
+          <p:cNvPicPr>
+            <a:picLocks noChangeAspect="1"/>
+          </p:cNvPicPr>
+          <p:nvPr/>
+        </p:nvPicPr>
+        <p:blipFill>
+          <a:blip r:embed="rId3"/>
+          <a:stretch>
+            <a:fillRect/>
+          </a:stretch>
+        </p:blipFill>
+        <p:spPr>
+          <a:xfrm>
+            <a:off x="4972050" y="889000"/>
+            <a:ext cx="6559550" cy="4555243"/>
+          </a:xfrm>
+          <a:prstGeom prst="rect">
+            <a:avLst/>
+          </a:prstGeom>
+          <a:ln>
+            <a:solidFill>
+              <a:srgbClr val="ECEAE5"/>
+            </a:solidFill>
+          </a:ln>
+        </p:spPr>
+      </p:pic>
+      <p:sp>
+        <p:nvSpPr>
+          <p:cNvPr id="5" name="TextBox 4"/>
           <p:cNvSpPr txBox="1"/>
           <p:nvPr/>
         </p:nvSpPr>
         <p:spPr>
           <a:xfrm>
-            <a:off x="660400" y="6223000"/>
-            <a:ext cx="10871200" cy="254000"/>
+            <a:off x="660400" y="6464300"/>
+            <a:ext cx="8890000" cy="190500"/>
           </a:xfrm>
           <a:prstGeom prst="rect">
             <a:avLst/>
@@ -3725,51 +4550,86 @@
           <a:noFill/>
         </p:spPr>
         <p:txBody>
-          <a:bodyPr wrap="square">
+          <a:bodyPr wrap="square" lIns="0" rIns="0" tIns="0" bIns="0">
             <a:spAutoFit/>
           </a:bodyPr>
           <a:lstStyle/>
           <a:p>
             <a:pPr>
-              <a:spcAft>
-                <a:spcPts val="600"/>
-              </a:spcAft>
+              <a:spcBef>
+                <a:spcPts val="0"/>
+              </a:spcBef>
             </a:pPr>
             <a:r>
-              <a:rPr sz="1000" b="0">
-                <a:solidFill>
-                  <a:srgbClr val="A1A1AA"/>
-                </a:solidFill>
-              </a:rPr>
-              <a:t>Week of Sep 28 · bolt.new/pricing · screenshot Oct 4 (archived copy)    Competitor watch</a:t>
-            </a:r>
-          </a:p>
-        </p:txBody>
-      </p:sp>
-      <p:pic>
-        <p:nvPicPr>
-          <p:cNvPr id="4" name="Picture 3" descr="bolt-pricing.jpg"/>
-          <p:cNvPicPr>
-            <a:picLocks noChangeAspect="1"/>
-          </p:cNvPicPr>
+              <a:rPr sz="900" b="0">
+                <a:solidFill>
+                  <a:srgbClr val="8A8780"/>
+                </a:solidFill>
+                <a:latin typeface="Inter"/>
+              </a:rPr>
+              <a:t>Deck for Mon, Oct 5 · Source: </a:t>
+            </a:r>
+            <a:r>
+              <a:rPr sz="900" b="0" u="sng">
+                <a:solidFill>
+                  <a:srgbClr val="8A8780"/>
+                </a:solidFill>
+                <a:latin typeface="Inter"/>
+                <a:hlinkClick r:id="rId2"/>
+              </a:rPr>
+              <a:t>replit.com</a:t>
+            </a:r>
+            <a:r>
+              <a:rPr sz="900" b="0">
+                <a:solidFill>
+                  <a:srgbClr val="8A8780"/>
+                </a:solidFill>
+                <a:latin typeface="Inter"/>
+              </a:rPr>
+              <a:t> · Screenshot Oct 3 · archived copy</a:t>
+            </a:r>
+          </a:p>
+        </p:txBody>
+      </p:sp>
+      <p:sp>
+        <p:nvSpPr>
+          <p:cNvPr id="6" name="TextBox 5"/>
+          <p:cNvSpPr txBox="1"/>
           <p:nvPr/>
-        </p:nvPicPr>
-        <p:blipFill>
-          <a:blip r:embed="rId2"/>
-          <a:stretch>
-            <a:fillRect/>
-          </a:stretch>
-        </p:blipFill>
+        </p:nvSpPr>
         <p:spPr>
           <a:xfrm>
-            <a:off x="4775200" y="609600"/>
-            <a:ext cx="6756400" cy="4691944"/>
+            <a:off x="9626600" y="6464300"/>
+            <a:ext cx="1905000" cy="190500"/>
           </a:xfrm>
           <a:prstGeom prst="rect">
             <a:avLst/>
           </a:prstGeom>
+          <a:noFill/>
         </p:spPr>
-      </p:pic>
+        <p:txBody>
+          <a:bodyPr wrap="square" lIns="0" rIns="0" tIns="0" bIns="0">
+            <a:spAutoFit/>
+          </a:bodyPr>
+          <a:lstStyle/>
+          <a:p>
+            <a:pPr algn="r">
+              <a:spcBef>
+                <a:spcPts val="0"/>
+              </a:spcBef>
+            </a:pPr>
+            <a:r>
+              <a:rPr sz="900" b="0">
+                <a:solidFill>
+                  <a:srgbClr val="8A8780"/>
+                </a:solidFill>
+                <a:latin typeface="Inter"/>
+              </a:rPr>
+              <a:t>Competitor watch</a:t>
+            </a:r>
+          </a:p>
+        </p:txBody>
+      </p:sp>
     </p:spTree>
   </p:cSld>
   <p:clrMapOvr>
@@ -3797,7 +4657,7 @@
         <p:spPr>
           <a:xfrm>
             <a:off x="660400" y="609600"/>
-            <a:ext cx="3556000" cy="5207000"/>
+            <a:ext cx="3778250" cy="5715000"/>
           </a:xfrm>
           <a:prstGeom prst="rect">
             <a:avLst/>
@@ -3805,52 +4665,239 @@
           <a:noFill/>
         </p:spPr>
         <p:txBody>
-          <a:bodyPr wrap="square">
+          <a:bodyPr wrap="square" lIns="0" rIns="0" tIns="0" bIns="0">
             <a:spAutoFit/>
           </a:bodyPr>
           <a:lstStyle/>
           <a:p>
             <a:pPr>
-              <a:spcAft>
-                <a:spcPts val="2160"/>
-              </a:spcAft>
+              <a:spcBef>
+                <a:spcPts val="0"/>
+              </a:spcBef>
             </a:pPr>
             <a:r>
-              <a:rPr sz="3600" b="1">
+              <a:rPr sz="900" b="0" cap="all" spc="90">
+                <a:solidFill>
+                  <a:srgbClr val="6B6964"/>
+                </a:solidFill>
+                <a:latin typeface="Inter"/>
+              </a:rPr>
+              <a:t>Bolt · Pricing page</a:t>
+            </a:r>
+          </a:p>
+          <a:p>
+            <a:pPr>
+              <a:spcBef>
+                <a:spcPts val="600"/>
+              </a:spcBef>
+            </a:pPr>
+            <a:r>
+              <a:rPr sz="4000" b="0" spc="-179">
                 <a:solidFill>
                   <a:srgbClr val="18181B"/>
                 </a:solidFill>
-              </a:rPr>
-              <a:t>Bolt homepage</a:t>
+                <a:latin typeface="Inter Tight"/>
+              </a:rPr>
+              <a:t>Bolt pricing</a:t>
             </a:r>
           </a:p>
           <a:p>
             <a:pPr>
-              <a:spcAft>
-                <a:spcPts val="1080"/>
-              </a:spcAft>
+              <a:spcBef>
+                <a:spcPts val="1000"/>
+              </a:spcBef>
             </a:pPr>
             <a:r>
-              <a:rPr sz="1800" b="0">
-                <a:solidFill>
-                  <a:srgbClr val="52525B"/>
-                </a:solidFill>
-              </a:rPr>
-              <a:t>No change this week</a:t>
-            </a:r>
-          </a:p>
-        </p:txBody>
-      </p:sp>
-      <p:sp>
-        <p:nvSpPr>
-          <p:cNvPr id="3" name="TextBox 2"/>
+              <a:rPr sz="1200" b="0">
+                <a:solidFill>
+                  <a:srgbClr val="FF6A00"/>
+                </a:solidFill>
+                <a:latin typeface="Inter"/>
+              </a:rPr>
+              <a:t>●  </a:t>
+            </a:r>
+            <a:r>
+              <a:rPr sz="1400" b="0">
+                <a:solidFill>
+                  <a:srgbClr val="44423E"/>
+                </a:solidFill>
+                <a:latin typeface="Inter"/>
+              </a:rPr>
+              <a:t>Changed this week · 2 changes</a:t>
+            </a:r>
+          </a:p>
+          <a:p>
+            <a:pPr>
+              <a:spcBef>
+                <a:spcPts val="2400"/>
+              </a:spcBef>
+            </a:pPr>
+            <a:r>
+              <a:rPr sz="1250" b="1">
+                <a:solidFill>
+                  <a:srgbClr val="C9C6BF"/>
+                </a:solidFill>
+                <a:latin typeface="Inter"/>
+              </a:rPr>
+              <a:t>—   </a:t>
+            </a:r>
+            <a:r>
+              <a:rPr sz="750" b="1" cap="all" spc="45">
+                <a:solidFill>
+                  <a:srgbClr val="166534"/>
+                </a:solidFill>
+                <a:latin typeface="Inter"/>
+              </a:rPr>
+              <a:t>Added   </a:t>
+            </a:r>
+            <a:r>
+              <a:rPr sz="1250" b="1">
+                <a:solidFill>
+                  <a:srgbClr val="18181B"/>
+                </a:solidFill>
+                <a:latin typeface="Inter"/>
+              </a:rPr>
+              <a:t>Bolt Lite ($9/month, invite only during the research preview) is powered by Bolt Forge and is the only AI mode on that plan.</a:t>
+            </a:r>
+          </a:p>
+          <a:p>
+            <a:pPr>
+              <a:spcBef>
+                <a:spcPts val="1000"/>
+              </a:spcBef>
+            </a:pPr>
+            <a:r>
+              <a:rPr sz="1250" b="1">
+                <a:solidFill>
+                  <a:srgbClr val="C9C6BF"/>
+                </a:solidFill>
+                <a:latin typeface="Inter"/>
+              </a:rPr>
+              <a:t>—   </a:t>
+            </a:r>
+            <a:r>
+              <a:rPr sz="750" b="1" cap="all" spc="45">
+                <a:solidFill>
+                  <a:srgbClr val="9A3412"/>
+                </a:solidFill>
+                <a:latin typeface="Inter"/>
+              </a:rPr>
+              <a:t>Removed   </a:t>
+            </a:r>
+            <a:r>
+              <a:rPr sz="1250" b="0" strike="sngStrike">
+                <a:solidFill>
+                  <a:srgbClr val="6B6964"/>
+                </a:solidFill>
+                <a:latin typeface="Inter"/>
+              </a:rPr>
+              <a:t>Bolt Lite ($9/month, invite only during the research preview) is powered by Bolt Forge and is the only AI mode on that plan.</a:t>
+            </a:r>
+          </a:p>
+        </p:txBody>
+      </p:sp>
+      <p:sp>
+        <p:nvSpPr>
+          <p:cNvPr id="3" name="Rectangle 2">
+            <a:hlinkClick r:id="rId2"/>
+          </p:cNvPr>
+          <p:cNvSpPr/>
+          <p:nvPr/>
+        </p:nvSpPr>
+        <p:spPr>
+          <a:xfrm>
+            <a:off x="4972050" y="609600"/>
+            <a:ext cx="6559550" cy="279400"/>
+          </a:xfrm>
+          <a:prstGeom prst="rect">
+            <a:avLst/>
+          </a:prstGeom>
+          <a:solidFill>
+            <a:srgbClr val="F7F6F3"/>
+          </a:solidFill>
+          <a:ln>
+            <a:solidFill>
+              <a:srgbClr val="ECEAE5"/>
+            </a:solidFill>
+          </a:ln>
+          <a:effectLst/>
+        </p:spPr>
+        <p:style>
+          <a:lnRef idx="1">
+            <a:schemeClr val="accent1"/>
+          </a:lnRef>
+          <a:fillRef idx="3">
+            <a:schemeClr val="accent1"/>
+          </a:fillRef>
+          <a:effectRef idx="2">
+            <a:schemeClr val="accent1"/>
+          </a:effectRef>
+          <a:fontRef idx="minor">
+            <a:schemeClr val="lt1"/>
+          </a:fontRef>
+        </p:style>
+        <p:txBody>
+          <a:bodyPr rtlCol="0" anchor="ctr" lIns="127000"/>
+          <a:lstStyle/>
+          <a:p>
+            <a:pPr algn="l">
+              <a:spcBef>
+                <a:spcPts val="0"/>
+              </a:spcBef>
+            </a:pPr>
+            <a:r>
+              <a:rPr sz="900" b="0">
+                <a:solidFill>
+                  <a:srgbClr val="6B6964"/>
+                </a:solidFill>
+                <a:latin typeface="Geist Mono"/>
+              </a:rPr>
+              <a:t>bolt.new/pricing</a:t>
+            </a:r>
+          </a:p>
+        </p:txBody>
+      </p:sp>
+      <p:pic>
+        <p:nvPicPr>
+          <p:cNvPr id="4" name="Picture 3" descr="bolt-pricing.jpg">
+            <a:hlinkClick r:id="rId2"/>
+          </p:cNvPr>
+          <p:cNvPicPr>
+            <a:picLocks noChangeAspect="1"/>
+          </p:cNvPicPr>
+          <p:nvPr/>
+        </p:nvPicPr>
+        <p:blipFill>
+          <a:blip r:embed="rId3"/>
+          <a:stretch>
+            <a:fillRect/>
+          </a:stretch>
+        </p:blipFill>
+        <p:spPr>
+          <a:xfrm>
+            <a:off x="4972050" y="889000"/>
+            <a:ext cx="6559550" cy="4555243"/>
+          </a:xfrm>
+          <a:prstGeom prst="rect">
+            <a:avLst/>
+          </a:prstGeom>
+          <a:ln>
+            <a:solidFill>
+              <a:srgbClr val="ECEAE5"/>
+            </a:solidFill>
+          </a:ln>
+        </p:spPr>
+      </p:pic>
+      <p:sp>
+        <p:nvSpPr>
+          <p:cNvPr id="5" name="TextBox 4"/>
           <p:cNvSpPr txBox="1"/>
           <p:nvPr/>
         </p:nvSpPr>
         <p:spPr>
           <a:xfrm>
-            <a:off x="660400" y="6223000"/>
-            <a:ext cx="10871200" cy="254000"/>
+            <a:off x="660400" y="6464300"/>
+            <a:ext cx="8890000" cy="190500"/>
           </a:xfrm>
           <a:prstGeom prst="rect">
             <a:avLst/>
@@ -3858,51 +4905,373 @@
           <a:noFill/>
         </p:spPr>
         <p:txBody>
-          <a:bodyPr wrap="square">
+          <a:bodyPr wrap="square" lIns="0" rIns="0" tIns="0" bIns="0">
             <a:spAutoFit/>
           </a:bodyPr>
           <a:lstStyle/>
           <a:p>
             <a:pPr>
-              <a:spcAft>
+              <a:spcBef>
+                <a:spcPts val="0"/>
+              </a:spcBef>
+            </a:pPr>
+            <a:r>
+              <a:rPr sz="900" b="0">
+                <a:solidFill>
+                  <a:srgbClr val="8A8780"/>
+                </a:solidFill>
+                <a:latin typeface="Inter"/>
+              </a:rPr>
+              <a:t>Deck for Mon, Oct 5 · Source: </a:t>
+            </a:r>
+            <a:r>
+              <a:rPr sz="900" b="0" u="sng">
+                <a:solidFill>
+                  <a:srgbClr val="8A8780"/>
+                </a:solidFill>
+                <a:latin typeface="Inter"/>
+                <a:hlinkClick r:id="rId2"/>
+              </a:rPr>
+              <a:t>bolt.new/pricing</a:t>
+            </a:r>
+            <a:r>
+              <a:rPr sz="900" b="0">
+                <a:solidFill>
+                  <a:srgbClr val="8A8780"/>
+                </a:solidFill>
+                <a:latin typeface="Inter"/>
+              </a:rPr>
+              <a:t> · Screenshot Oct 4 · archived copy</a:t>
+            </a:r>
+          </a:p>
+        </p:txBody>
+      </p:sp>
+      <p:sp>
+        <p:nvSpPr>
+          <p:cNvPr id="6" name="TextBox 5"/>
+          <p:cNvSpPr txBox="1"/>
+          <p:nvPr/>
+        </p:nvSpPr>
+        <p:spPr>
+          <a:xfrm>
+            <a:off x="9626600" y="6464300"/>
+            <a:ext cx="1905000" cy="190500"/>
+          </a:xfrm>
+          <a:prstGeom prst="rect">
+            <a:avLst/>
+          </a:prstGeom>
+          <a:noFill/>
+        </p:spPr>
+        <p:txBody>
+          <a:bodyPr wrap="square" lIns="0" rIns="0" tIns="0" bIns="0">
+            <a:spAutoFit/>
+          </a:bodyPr>
+          <a:lstStyle/>
+          <a:p>
+            <a:pPr algn="r">
+              <a:spcBef>
+                <a:spcPts val="0"/>
+              </a:spcBef>
+            </a:pPr>
+            <a:r>
+              <a:rPr sz="900" b="0">
+                <a:solidFill>
+                  <a:srgbClr val="8A8780"/>
+                </a:solidFill>
+                <a:latin typeface="Inter"/>
+              </a:rPr>
+              <a:t>Competitor watch</a:t>
+            </a:r>
+          </a:p>
+        </p:txBody>
+      </p:sp>
+    </p:spTree>
+  </p:cSld>
+  <p:clrMapOvr>
+    <a:masterClrMapping/>
+  </p:clrMapOvr>
+</p:sld>
+</file>
+
+<file path=ppt/slides/slide7.xml><?xml version="1.0" encoding="utf-8"?>
+<p:sld xmlns:a="http://schemas.openxmlformats.org/drawingml/2006/main" xmlns:p="http://schemas.openxmlformats.org/presentationml/2006/main" xmlns:r="http://schemas.openxmlformats.org/officeDocument/2006/relationships">
+  <p:cSld>
+    <p:spTree>
+      <p:nvGrpSpPr>
+        <p:cNvPr id="1" name=""/>
+        <p:cNvGrpSpPr/>
+        <p:nvPr/>
+      </p:nvGrpSpPr>
+      <p:grpSpPr/>
+      <p:sp>
+        <p:nvSpPr>
+          <p:cNvPr id="2" name="TextBox 1"/>
+          <p:cNvSpPr txBox="1"/>
+          <p:nvPr/>
+        </p:nvSpPr>
+        <p:spPr>
+          <a:xfrm>
+            <a:off x="660400" y="609600"/>
+            <a:ext cx="3778250" cy="5715000"/>
+          </a:xfrm>
+          <a:prstGeom prst="rect">
+            <a:avLst/>
+          </a:prstGeom>
+          <a:noFill/>
+        </p:spPr>
+        <p:txBody>
+          <a:bodyPr wrap="square" lIns="0" rIns="0" tIns="0" bIns="0">
+            <a:spAutoFit/>
+          </a:bodyPr>
+          <a:lstStyle/>
+          <a:p>
+            <a:pPr>
+              <a:spcBef>
+                <a:spcPts val="0"/>
+              </a:spcBef>
+            </a:pPr>
+            <a:r>
+              <a:rPr sz="900" b="0" cap="all" spc="90">
+                <a:solidFill>
+                  <a:srgbClr val="6B6964"/>
+                </a:solidFill>
+                <a:latin typeface="Inter"/>
+              </a:rPr>
+              <a:t>Bolt · Homepage</a:t>
+            </a:r>
+          </a:p>
+          <a:p>
+            <a:pPr>
+              <a:spcBef>
                 <a:spcPts val="600"/>
-              </a:spcAft>
+              </a:spcBef>
             </a:pPr>
             <a:r>
-              <a:rPr sz="1000" b="0">
-                <a:solidFill>
-                  <a:srgbClr val="A1A1AA"/>
-                </a:solidFill>
-              </a:rPr>
-              <a:t>Week of Sep 28 · bolt.new · screenshot Oct 4 (archived copy)    Competitor watch</a:t>
+              <a:rPr sz="4000" b="0" spc="-179">
+                <a:solidFill>
+                  <a:srgbClr val="18181B"/>
+                </a:solidFill>
+                <a:latin typeface="Inter Tight"/>
+              </a:rPr>
+              <a:t>Bolt homepage</a:t>
+            </a:r>
+          </a:p>
+          <a:p>
+            <a:pPr>
+              <a:spcBef>
+                <a:spcPts val="1000"/>
+              </a:spcBef>
+            </a:pPr>
+            <a:r>
+              <a:rPr sz="1200" b="0">
+                <a:solidFill>
+                  <a:srgbClr val="D6D3CC"/>
+                </a:solidFill>
+                <a:latin typeface="Inter"/>
+              </a:rPr>
+              <a:t>●  </a:t>
+            </a:r>
+            <a:r>
+              <a:rPr sz="1400" b="0">
+                <a:solidFill>
+                  <a:srgbClr val="44423E"/>
+                </a:solidFill>
+                <a:latin typeface="Inter"/>
+              </a:rPr>
+              <a:t>No change this week</a:t>
+            </a:r>
+          </a:p>
+        </p:txBody>
+      </p:sp>
+      <p:sp>
+        <p:nvSpPr>
+          <p:cNvPr id="3" name="Rectangle 2">
+            <a:hlinkClick r:id="rId2"/>
+          </p:cNvPr>
+          <p:cNvSpPr/>
+          <p:nvPr/>
+        </p:nvSpPr>
+        <p:spPr>
+          <a:xfrm>
+            <a:off x="4972050" y="609600"/>
+            <a:ext cx="6559550" cy="279400"/>
+          </a:xfrm>
+          <a:prstGeom prst="rect">
+            <a:avLst/>
+          </a:prstGeom>
+          <a:solidFill>
+            <a:srgbClr val="F7F6F3"/>
+          </a:solidFill>
+          <a:ln>
+            <a:solidFill>
+              <a:srgbClr val="ECEAE5"/>
+            </a:solidFill>
+          </a:ln>
+          <a:effectLst/>
+        </p:spPr>
+        <p:style>
+          <a:lnRef idx="1">
+            <a:schemeClr val="accent1"/>
+          </a:lnRef>
+          <a:fillRef idx="3">
+            <a:schemeClr val="accent1"/>
+          </a:fillRef>
+          <a:effectRef idx="2">
+            <a:schemeClr val="accent1"/>
+          </a:effectRef>
+          <a:fontRef idx="minor">
+            <a:schemeClr val="lt1"/>
+          </a:fontRef>
+        </p:style>
+        <p:txBody>
+          <a:bodyPr rtlCol="0" anchor="ctr" lIns="127000"/>
+          <a:lstStyle/>
+          <a:p>
+            <a:pPr algn="l">
+              <a:spcBef>
+                <a:spcPts val="0"/>
+              </a:spcBef>
+            </a:pPr>
+            <a:r>
+              <a:rPr sz="900" b="0">
+                <a:solidFill>
+                  <a:srgbClr val="6B6964"/>
+                </a:solidFill>
+                <a:latin typeface="Geist Mono"/>
+              </a:rPr>
+              <a:t>bolt.new</a:t>
             </a:r>
           </a:p>
         </p:txBody>
       </p:sp>
       <p:pic>
         <p:nvPicPr>
-          <p:cNvPr id="4" name="Picture 3" descr="bolt-home.jpg"/>
+          <p:cNvPr id="4" name="Picture 3" descr="bolt-home.jpg">
+            <a:hlinkClick r:id="rId2"/>
+          </p:cNvPr>
           <p:cNvPicPr>
             <a:picLocks noChangeAspect="1"/>
           </p:cNvPicPr>
           <p:nvPr/>
         </p:nvPicPr>
         <p:blipFill>
-          <a:blip r:embed="rId2"/>
+          <a:blip r:embed="rId3"/>
           <a:stretch>
             <a:fillRect/>
           </a:stretch>
         </p:blipFill>
         <p:spPr>
           <a:xfrm>
-            <a:off x="4775200" y="609600"/>
-            <a:ext cx="6756400" cy="4691944"/>
+            <a:off x="4972050" y="889000"/>
+            <a:ext cx="6559550" cy="4555243"/>
           </a:xfrm>
           <a:prstGeom prst="rect">
             <a:avLst/>
           </a:prstGeom>
+          <a:ln>
+            <a:solidFill>
+              <a:srgbClr val="ECEAE5"/>
+            </a:solidFill>
+          </a:ln>
         </p:spPr>
       </p:pic>
+      <p:sp>
+        <p:nvSpPr>
+          <p:cNvPr id="5" name="TextBox 4"/>
+          <p:cNvSpPr txBox="1"/>
+          <p:nvPr/>
+        </p:nvSpPr>
+        <p:spPr>
+          <a:xfrm>
+            <a:off x="660400" y="6464300"/>
+            <a:ext cx="8890000" cy="190500"/>
+          </a:xfrm>
+          <a:prstGeom prst="rect">
+            <a:avLst/>
+          </a:prstGeom>
+          <a:noFill/>
+        </p:spPr>
+        <p:txBody>
+          <a:bodyPr wrap="square" lIns="0" rIns="0" tIns="0" bIns="0">
+            <a:spAutoFit/>
+          </a:bodyPr>
+          <a:lstStyle/>
+          <a:p>
+            <a:pPr>
+              <a:spcBef>
+                <a:spcPts val="0"/>
+              </a:spcBef>
+            </a:pPr>
+            <a:r>
+              <a:rPr sz="900" b="0">
+                <a:solidFill>
+                  <a:srgbClr val="8A8780"/>
+                </a:solidFill>
+                <a:latin typeface="Inter"/>
+              </a:rPr>
+              <a:t>Deck for Mon, Oct 5 · Source: </a:t>
+            </a:r>
+            <a:r>
+              <a:rPr sz="900" b="0" u="sng">
+                <a:solidFill>
+                  <a:srgbClr val="8A8780"/>
+                </a:solidFill>
+                <a:latin typeface="Inter"/>
+                <a:hlinkClick r:id="rId2"/>
+              </a:rPr>
+              <a:t>bolt.new</a:t>
+            </a:r>
+            <a:r>
+              <a:rPr sz="900" b="0">
+                <a:solidFill>
+                  <a:srgbClr val="8A8780"/>
+                </a:solidFill>
+                <a:latin typeface="Inter"/>
+              </a:rPr>
+              <a:t> · Screenshot Oct 4 · archived copy</a:t>
+            </a:r>
+          </a:p>
+        </p:txBody>
+      </p:sp>
+      <p:sp>
+        <p:nvSpPr>
+          <p:cNvPr id="6" name="TextBox 5"/>
+          <p:cNvSpPr txBox="1"/>
+          <p:nvPr/>
+        </p:nvSpPr>
+        <p:spPr>
+          <a:xfrm>
+            <a:off x="9626600" y="6464300"/>
+            <a:ext cx="1905000" cy="190500"/>
+          </a:xfrm>
+          <a:prstGeom prst="rect">
+            <a:avLst/>
+          </a:prstGeom>
+          <a:noFill/>
+        </p:spPr>
+        <p:txBody>
+          <a:bodyPr wrap="square" lIns="0" rIns="0" tIns="0" bIns="0">
+            <a:spAutoFit/>
+          </a:bodyPr>
+          <a:lstStyle/>
+          <a:p>
+            <a:pPr algn="r">
+              <a:spcBef>
+                <a:spcPts val="0"/>
+              </a:spcBef>
+            </a:pPr>
+            <a:r>
+              <a:rPr sz="900" b="0">
+                <a:solidFill>
+                  <a:srgbClr val="8A8780"/>
+                </a:solidFill>
+                <a:latin typeface="Inter"/>
+              </a:rPr>
+              <a:t>Competitor watch</a:t>
+            </a:r>
+          </a:p>
+        </p:txBody>
+      </p:sp>
     </p:spTree>
   </p:cSld>
   <p:clrMapOvr>
@@ -3946,10 +5315,10 @@
         <a:srgbClr val="F79646"/>
       </a:accent6>
       <a:hlink>
-        <a:srgbClr val="0000FF"/>
+        <a:srgbClr val="44423E"/>
       </a:hlink>
       <a:folHlink>
-        <a:srgbClr val="800080"/>
+        <a:srgbClr val="44423E"/>
       </a:folHlink>
     </a:clrScheme>
     <a:fontScheme name="Office">

</xml_diff>